<commit_message>
Set report template text to Malgun Gothic with Korean language
Text runs had no East Asian font and en-US language, so PowerPoint picked a
fallback Hangul font. Every run, the layout placeholders and the theme's East
Asian font now name 맑은 고딕, with the Hangul charset.

Co-Authored-By: Claude Opus 5.5 <noreply@anthropic.com>
Claude-Session: https://claude.ai/code/session_014YmWvhizxd7vDhF58tq42A
</commit_message>
<xml_diff>
--- a/word-practice/files/report-template.pptx
+++ b/word-practice/files/report-template.pptx
@@ -622,10 +622,13 @@
           <a:lstStyle>
             <a:lvl1pPr algn="l" indent="0" marL="0">
               <a:buNone/>
-              <a:defRPr lang="en-US" sz="2800" b="1" dirty="0">
+              <a:defRPr lang="ko-KR" altLang="en-US" sz="2800" b="1" dirty="0">
                 <a:solidFill>
                   <a:schemeClr val="tx1"/>
                 </a:solidFill>
+                <a:latin typeface="맑은 고딕" pitchFamily="34" charset="0"/>
+                <a:ea typeface="맑은 고딕" pitchFamily="34" charset="-127"/>
+                <a:cs typeface="맑은 고딕" pitchFamily="34" charset="-120"/>
               </a:defRPr>
             </a:lvl1pPr>
           </a:lstStyle>
@@ -634,14 +637,17 @@
               <a:buNone/>
             </a:pPr>
             <a:r>
-              <a:rPr lang="en-US" sz="2800" b="1" dirty="0">
+              <a:rPr lang="ko-KR" altLang="en-US" sz="2800" b="1" dirty="0">
                 <a:solidFill>
                   <a:schemeClr val="tx1"/>
                 </a:solidFill>
+                <a:latin typeface="맑은 고딕" pitchFamily="34" charset="0"/>
+                <a:ea typeface="맑은 고딕" pitchFamily="34" charset="-127"/>
+                <a:cs typeface="맑은 고딕" pitchFamily="34" charset="-120"/>
               </a:rPr>
               <a:t>자급제 폰 시장 보고</a:t>
             </a:r>
-            <a:endParaRPr lang="en-US" sz="2800" dirty="0"/>
+            <a:endParaRPr lang="ko-KR" sz="2800" dirty="0"/>
           </a:p>
         </p:txBody>
       </p:sp>
@@ -669,10 +675,13 @@
           <a:lstStyle>
             <a:lvl1pPr indent="0" marL="0">
               <a:buNone/>
-              <a:defRPr lang="en-US" sz="1300" dirty="0">
+              <a:defRPr lang="ko-KR" altLang="en-US" sz="1300" dirty="0">
                 <a:solidFill>
                   <a:schemeClr val="accent5"/>
                 </a:solidFill>
+                <a:latin typeface="맑은 고딕" pitchFamily="34" charset="0"/>
+                <a:ea typeface="맑은 고딕" pitchFamily="34" charset="-127"/>
+                <a:cs typeface="맑은 고딕" pitchFamily="34" charset="-120"/>
               </a:defRPr>
             </a:lvl1pPr>
           </a:lstStyle>
@@ -681,14 +690,17 @@
               <a:buNone/>
             </a:pPr>
             <a:r>
-              <a:rPr lang="en-US" sz="1300" dirty="0">
+              <a:rPr lang="ko-KR" altLang="en-US" sz="1300" dirty="0">
                 <a:solidFill>
                   <a:schemeClr val="accent5"/>
                 </a:solidFill>
+                <a:latin typeface="맑은 고딕" pitchFamily="34" charset="0"/>
+                <a:ea typeface="맑은 고딕" pitchFamily="34" charset="-127"/>
+                <a:cs typeface="맑은 고딕" pitchFamily="34" charset="-120"/>
               </a:rPr>
               <a:t>1-2반 ○번 이름 · 2026. 10. 27.</a:t>
             </a:r>
-            <a:endParaRPr lang="en-US" sz="1300" dirty="0"/>
+            <a:endParaRPr lang="ko-KR" sz="1300" dirty="0"/>
           </a:p>
         </p:txBody>
       </p:sp>
@@ -1022,14 +1034,17 @@
               <a:buNone/>
             </a:pPr>
             <a:r>
-              <a:rPr lang="en-US" sz="2800" b="1" dirty="0">
+              <a:rPr lang="ko-KR" altLang="en-US" sz="2800" b="1" dirty="0">
                 <a:solidFill>
                   <a:schemeClr val="tx1"/>
                 </a:solidFill>
+                <a:latin typeface="맑은 고딕" pitchFamily="34" charset="0"/>
+                <a:ea typeface="맑은 고딕" pitchFamily="34" charset="-127"/>
+                <a:cs typeface="맑은 고딕" pitchFamily="34" charset="-120"/>
               </a:rPr>
               <a:t>자급제 폰 시장 보고</a:t>
             </a:r>
-            <a:endParaRPr lang="en-US" sz="2800" dirty="0"/>
+            <a:endParaRPr lang="ko-KR" sz="2800" dirty="0"/>
           </a:p>
         </p:txBody>
       </p:sp>
@@ -1060,14 +1075,17 @@
               <a:buNone/>
             </a:pPr>
             <a:r>
-              <a:rPr lang="en-US" sz="1300" dirty="0">
+              <a:rPr lang="ko-KR" altLang="en-US" sz="1300" dirty="0">
                 <a:solidFill>
                   <a:schemeClr val="accent5"/>
                 </a:solidFill>
+                <a:latin typeface="맑은 고딕" pitchFamily="34" charset="0"/>
+                <a:ea typeface="맑은 고딕" pitchFamily="34" charset="-127"/>
+                <a:cs typeface="맑은 고딕" pitchFamily="34" charset="-120"/>
               </a:rPr>
               <a:t>1-2반 ○번 이름 · 2026. 10. 27.</a:t>
             </a:r>
-            <a:endParaRPr lang="en-US" sz="1300" dirty="0"/>
+            <a:endParaRPr lang="ko-KR" sz="1300" dirty="0"/>
           </a:p>
         </p:txBody>
       </p:sp>
@@ -1123,28 +1141,34 @@
               <a:buNone/>
             </a:pPr>
             <a:r>
-              <a:rPr lang="en-US" sz="1600" b="1" dirty="0">
+              <a:rPr lang="ko-KR" altLang="en-US" sz="1600" b="1" dirty="0">
                 <a:solidFill>
                   <a:schemeClr val="accent1"/>
                 </a:solidFill>
+                <a:latin typeface="맑은 고딕" pitchFamily="34" charset="0"/>
+                <a:ea typeface="맑은 고딕" pitchFamily="34" charset="-127"/>
+                <a:cs typeface="맑은 고딕" pitchFamily="34" charset="-120"/>
               </a:rPr>
               <a:t>여기에 한글 차트 붙여넣기</a:t>
             </a:r>
-            <a:endParaRPr lang="en-US" sz="1600" dirty="0"/>
+            <a:endParaRPr lang="ko-KR" sz="1600" dirty="0"/>
           </a:p>
           <a:p>
             <a:pPr algn="ctr" indent="0" marL="0">
               <a:buNone/>
             </a:pPr>
             <a:r>
-              <a:rPr lang="en-US" sz="1200" dirty="0">
+              <a:rPr lang="ko-KR" altLang="en-US" sz="1200" dirty="0">
                 <a:solidFill>
                   <a:schemeClr val="tx1"/>
                 </a:solidFill>
+                <a:latin typeface="맑은 고딕" pitchFamily="34" charset="0"/>
+                <a:ea typeface="맑은 고딕" pitchFamily="34" charset="-127"/>
+                <a:cs typeface="맑은 고딕" pitchFamily="34" charset="-120"/>
               </a:rPr>
               <a:t>차트 클릭 → Ctrl+C → 이 칸 클릭 → Ctrl+V</a:t>
             </a:r>
-            <a:endParaRPr lang="en-US" sz="1600" dirty="0"/>
+            <a:endParaRPr lang="ko-KR" sz="1600" dirty="0"/>
           </a:p>
         </p:txBody>
       </p:sp>
@@ -1173,14 +1197,17 @@
               <a:buNone/>
             </a:pPr>
             <a:r>
-              <a:rPr lang="en-US" sz="1500" b="1" dirty="0">
+              <a:rPr lang="ko-KR" altLang="en-US" sz="1500" b="1" dirty="0">
                 <a:solidFill>
                   <a:schemeClr val="tx1"/>
                 </a:solidFill>
+                <a:latin typeface="맑은 고딕" pitchFamily="34" charset="0"/>
+                <a:ea typeface="맑은 고딕" pitchFamily="34" charset="-127"/>
+                <a:cs typeface="맑은 고딕" pitchFamily="34" charset="-120"/>
               </a:rPr>
               <a:t>핵심 숫자 3줄</a:t>
             </a:r>
-            <a:endParaRPr lang="en-US" sz="1500" dirty="0"/>
+            <a:endParaRPr lang="ko-KR" sz="1500" dirty="0"/>
           </a:p>
         </p:txBody>
       </p:sp>
@@ -1234,14 +1261,17 @@
               <a:buNone/>
             </a:pPr>
             <a:r>
-              <a:rPr lang="en-US" sz="1400" b="1" dirty="0">
+              <a:rPr lang="ko-KR" altLang="en-US" sz="1400" b="1" dirty="0">
                 <a:solidFill>
                   <a:schemeClr val="bg1"/>
                 </a:solidFill>
+                <a:latin typeface="맑은 고딕" pitchFamily="34" charset="0"/>
+                <a:ea typeface="맑은 고딕" pitchFamily="34" charset="-127"/>
+                <a:cs typeface="맑은 고딕" pitchFamily="34" charset="-120"/>
               </a:rPr>
               <a:t>1</a:t>
             </a:r>
-            <a:endParaRPr lang="en-US" sz="1400" dirty="0"/>
+            <a:endParaRPr lang="ko-KR" sz="1400" dirty="0"/>
           </a:p>
         </p:txBody>
       </p:sp>
@@ -1270,14 +1300,17 @@
               <a:buNone/>
             </a:pPr>
             <a:r>
-              <a:rPr lang="en-US" sz="1400" dirty="0">
+              <a:rPr lang="ko-KR" altLang="en-US" sz="1400" dirty="0">
                 <a:solidFill>
                   <a:schemeClr val="tx1"/>
                 </a:solidFill>
+                <a:latin typeface="맑은 고딕" pitchFamily="34" charset="0"/>
+                <a:ea typeface="맑은 고딕" pitchFamily="34" charset="-127"/>
+                <a:cs typeface="맑은 고딕" pitchFamily="34" charset="-120"/>
               </a:rPr>
               <a:t>자급제 사용자 ___ → ___ 십만 대</a:t>
             </a:r>
-            <a:endParaRPr lang="en-US" sz="1400" dirty="0"/>
+            <a:endParaRPr lang="ko-KR" sz="1400" dirty="0"/>
           </a:p>
         </p:txBody>
       </p:sp>
@@ -1331,14 +1364,17 @@
               <a:buNone/>
             </a:pPr>
             <a:r>
-              <a:rPr lang="en-US" sz="1400" b="1" dirty="0">
+              <a:rPr lang="ko-KR" altLang="en-US" sz="1400" b="1" dirty="0">
                 <a:solidFill>
                   <a:schemeClr val="bg1"/>
                 </a:solidFill>
+                <a:latin typeface="맑은 고딕" pitchFamily="34" charset="0"/>
+                <a:ea typeface="맑은 고딕" pitchFamily="34" charset="-127"/>
+                <a:cs typeface="맑은 고딕" pitchFamily="34" charset="-120"/>
               </a:rPr>
               <a:t>2</a:t>
             </a:r>
-            <a:endParaRPr lang="en-US" sz="1400" dirty="0"/>
+            <a:endParaRPr lang="ko-KR" sz="1400" dirty="0"/>
           </a:p>
         </p:txBody>
       </p:sp>
@@ -1367,14 +1403,17 @@
               <a:buNone/>
             </a:pPr>
             <a:r>
-              <a:rPr lang="en-US" sz="1400" dirty="0">
+              <a:rPr lang="ko-KR" altLang="en-US" sz="1400" dirty="0">
                 <a:solidFill>
                   <a:schemeClr val="tx1"/>
                 </a:solidFill>
+                <a:latin typeface="맑은 고딕" pitchFamily="34" charset="0"/>
+                <a:ea typeface="맑은 고딕" pitchFamily="34" charset="-127"/>
+                <a:cs typeface="맑은 고딕" pitchFamily="34" charset="-120"/>
               </a:rPr>
               <a:t>자급제 비중 ___% → ___%</a:t>
             </a:r>
-            <a:endParaRPr lang="en-US" sz="1400" dirty="0"/>
+            <a:endParaRPr lang="ko-KR" sz="1400" dirty="0"/>
           </a:p>
         </p:txBody>
       </p:sp>
@@ -1428,14 +1467,17 @@
               <a:buNone/>
             </a:pPr>
             <a:r>
-              <a:rPr lang="en-US" sz="1400" b="1" dirty="0">
+              <a:rPr lang="ko-KR" altLang="en-US" sz="1400" b="1" dirty="0">
                 <a:solidFill>
                   <a:schemeClr val="bg1"/>
                 </a:solidFill>
+                <a:latin typeface="맑은 고딕" pitchFamily="34" charset="0"/>
+                <a:ea typeface="맑은 고딕" pitchFamily="34" charset="-127"/>
+                <a:cs typeface="맑은 고딕" pitchFamily="34" charset="-120"/>
               </a:rPr>
               <a:t>3</a:t>
             </a:r>
-            <a:endParaRPr lang="en-US" sz="1400" dirty="0"/>
+            <a:endParaRPr lang="ko-KR" sz="1400" dirty="0"/>
           </a:p>
         </p:txBody>
       </p:sp>
@@ -1464,14 +1506,17 @@
               <a:buNone/>
             </a:pPr>
             <a:r>
-              <a:rPr lang="en-US" sz="1400" dirty="0">
+              <a:rPr lang="ko-KR" altLang="en-US" sz="1400" dirty="0">
                 <a:solidFill>
                   <a:schemeClr val="tx1"/>
                 </a:solidFill>
+                <a:latin typeface="맑은 고딕" pitchFamily="34" charset="0"/>
+                <a:ea typeface="맑은 고딕" pitchFamily="34" charset="-127"/>
+                <a:cs typeface="맑은 고딕" pitchFamily="34" charset="-120"/>
               </a:rPr>
               <a:t>전체 가입자 ___ → ___ 십만 대</a:t>
             </a:r>
-            <a:endParaRPr lang="en-US" sz="1400" dirty="0"/>
+            <a:endParaRPr lang="ko-KR" sz="1400" dirty="0"/>
           </a:p>
         </p:txBody>
       </p:sp>
@@ -1527,10 +1572,13 @@
               <a:buNone/>
             </a:pPr>
             <a:r>
-              <a:rPr lang="en-US" sz="1500" b="1" dirty="0">
+              <a:rPr lang="ko-KR" altLang="en-US" sz="1500" b="1" dirty="0">
                 <a:solidFill>
                   <a:schemeClr val="tx1"/>
                 </a:solidFill>
+                <a:latin typeface="맑은 고딕" pitchFamily="34" charset="0"/>
+                <a:ea typeface="맑은 고딕" pitchFamily="34" charset="-127"/>
+                <a:cs typeface="맑은 고딕" pitchFamily="34" charset="-120"/>
               </a:rPr>
               <a:t>결론  </a:t>
             </a:r>
@@ -1538,14 +1586,17 @@
               <a:buNone/>
             </a:pPr>
             <a:r>
-              <a:rPr lang="en-US" sz="1500" dirty="0">
+              <a:rPr lang="ko-KR" altLang="en-US" sz="1500" dirty="0">
                 <a:solidFill>
                   <a:schemeClr val="tx1"/>
                 </a:solidFill>
+                <a:latin typeface="맑은 고딕" pitchFamily="34" charset="0"/>
+                <a:ea typeface="맑은 고딕" pitchFamily="34" charset="-127"/>
+                <a:cs typeface="맑은 고딕" pitchFamily="34" charset="-120"/>
               </a:rPr>
               <a:t>그래서 우리 회사는 ________________ 해야 합니다.</a:t>
             </a:r>
-            <a:endParaRPr lang="en-US" sz="1500" dirty="0"/>
+            <a:endParaRPr lang="ko-KR" sz="1500" dirty="0"/>
           </a:p>
         </p:txBody>
       </p:sp>
@@ -1600,8 +1651,8 @@
     </a:clrScheme>
     <a:fontScheme name="Report Blue">
       <a:majorFont>
-        <a:latin typeface="Malgun Gothic"/>
-        <a:ea typeface=""/>
+        <a:latin typeface="맑은 고딕"/>
+        <a:ea typeface="맑은 고딕"/>
         <a:cs typeface=""/>
         <a:font script="Jpan" typeface="游ゴシック Light"/>
         <a:font script="Hang" typeface="맑은 고딕"/>
@@ -1652,8 +1703,8 @@
         <a:font script="Tfng" typeface="Ebrima"/>
       </a:majorFont>
       <a:minorFont>
-        <a:latin typeface="Malgun Gothic"/>
-        <a:ea typeface=""/>
+        <a:latin typeface="맑은 고딕"/>
+        <a:ea typeface="맑은 고딕"/>
         <a:cs typeface=""/>
         <a:font script="Jpan" typeface="游ゴシック"/>
         <a:font script="Hang" typeface="맑은 고딕"/>

</xml_diff>